<commit_message>
Use Segoe UI for slide headings so Vietnamese diacritics render correctly
</commit_message>
<xml_diff>
--- a/slides/BreakBite_Lab2_Presentation.pptx
+++ b/slides/BreakBite_Lab2_Presentation.pptx
@@ -3444,7 +3444,7 @@
                 <a:solidFill>
                   <a:srgbClr val="622B14"/>
                 </a:solidFill>
-                <a:latin typeface="Trebuchet MS"/>
+                <a:latin typeface="Segoe UI"/>
               </a:rPr>
               <a:t>BreakBite</a:t>
             </a:r>
@@ -3483,7 +3483,7 @@
                 <a:solidFill>
                   <a:srgbClr val="B45309"/>
                 </a:solidFill>
-                <a:latin typeface="Trebuchet MS"/>
+                <a:latin typeface="Segoe UI"/>
               </a:rPr>
               <a:t>Đặt món trước, nhận tại quầy.</a:t>
             </a:r>
@@ -3880,7 +3880,7 @@
                 <a:solidFill>
                   <a:srgbClr val="622B14"/>
                 </a:solidFill>
-                <a:latin typeface="Trebuchet MS"/>
+                <a:latin typeface="Segoe UI"/>
               </a:rPr>
               <a:t>User story chính</a:t>
             </a:r>
@@ -5010,7 +5010,7 @@
                 <a:solidFill>
                   <a:srgbClr val="622B14"/>
                 </a:solidFill>
-                <a:latin typeface="Trebuchet MS"/>
+                <a:latin typeface="Segoe UI"/>
               </a:rPr>
               <a:t>Kiến trúc thông tin</a:t>
             </a:r>
@@ -6575,7 +6575,7 @@
                 <a:solidFill>
                   <a:srgbClr val="622B14"/>
                 </a:solidFill>
-                <a:latin typeface="Trebuchet MS"/>
+                <a:latin typeface="Segoe UI"/>
               </a:rPr>
               <a:t>Ba flow chính</a:t>
             </a:r>
@@ -9504,7 +9504,7 @@
                 <a:solidFill>
                   <a:srgbClr val="622B14"/>
                 </a:solidFill>
-                <a:latin typeface="Trebuchet MS"/>
+                <a:latin typeface="Segoe UI"/>
               </a:rPr>
               <a:t>Wireframe và flow mở rộng</a:t>
             </a:r>
@@ -10710,7 +10710,7 @@
                 <a:solidFill>
                   <a:srgbClr val="622B14"/>
                 </a:solidFill>
-                <a:latin typeface="Trebuchet MS"/>
+                <a:latin typeface="Segoe UI"/>
               </a:rPr>
               <a:t>Tạo giao diện với Google Stitch</a:t>
             </a:r>
@@ -11134,7 +11134,7 @@
                 <a:solidFill>
                   <a:srgbClr val="622B14"/>
                 </a:solidFill>
-                <a:latin typeface="Trebuchet MS"/>
+                <a:latin typeface="Segoe UI"/>
               </a:rPr>
               <a:t>DESIGN.md</a:t>
             </a:r>
@@ -11324,7 +11324,7 @@
                 <a:solidFill>
                   <a:srgbClr val="622B14"/>
                 </a:solidFill>
-                <a:latin typeface="Trebuchet MS"/>
+                <a:latin typeface="Segoe UI"/>
               </a:rPr>
               <a:t>Prompt gửi Stitch</a:t>
             </a:r>
@@ -11514,7 +11514,7 @@
                 <a:solidFill>
                   <a:srgbClr val="622B14"/>
                 </a:solidFill>
-                <a:latin typeface="Trebuchet MS"/>
+                <a:latin typeface="Segoe UI"/>
               </a:rPr>
               <a:t>Bốn màn ban đầu</a:t>
             </a:r>
@@ -11704,7 +11704,7 @@
                 <a:solidFill>
                   <a:srgbClr val="622B14"/>
                 </a:solidFill>
-                <a:latin typeface="Trebuchet MS"/>
+                <a:latin typeface="Segoe UI"/>
               </a:rPr>
               <a:t>Nhật ký</a:t>
             </a:r>
@@ -11926,7 +11926,7 @@
                 <a:solidFill>
                   <a:srgbClr val="622B14"/>
                 </a:solidFill>
-                <a:latin typeface="Trebuchet MS"/>
+                <a:latin typeface="Segoe UI"/>
               </a:rPr>
               <a:t>Ba hướng visual cho màn Trang chủ</a:t>
             </a:r>
@@ -13314,7 +13314,7 @@
                 <a:solidFill>
                   <a:srgbClr val="622B14"/>
                 </a:solidFill>
-                <a:latin typeface="Trebuchet MS"/>
+                <a:latin typeface="Segoe UI"/>
               </a:rPr>
               <a:t>AI phản biện và ba vòng tinh chỉnh</a:t>
             </a:r>
@@ -13738,7 +13738,7 @@
                 <a:solidFill>
                   <a:srgbClr val="622B14"/>
                 </a:solidFill>
-                <a:latin typeface="Trebuchet MS"/>
+                <a:latin typeface="Segoe UI"/>
               </a:rPr>
               <a:t>CTA khó đọc, bị chìm</a:t>
             </a:r>
@@ -13944,7 +13944,7 @@
                 <a:solidFill>
                   <a:srgbClr val="622B14"/>
                 </a:solidFill>
-                <a:latin typeface="Trebuchet MS"/>
+                <a:latin typeface="Segoe UI"/>
               </a:rPr>
               <a:t>Thiếu giỏ trống, dễ xoá nhầm</a:t>
             </a:r>
@@ -14150,7 +14150,7 @@
                 <a:solidFill>
                   <a:srgbClr val="622B14"/>
                 </a:solidFill>
-                <a:latin typeface="Trebuchet MS"/>
+                <a:latin typeface="Segoe UI"/>
               </a:rPr>
               <a:t>Lỗi thanh toán là ngõ cụt</a:t>
             </a:r>
@@ -14441,7 +14441,7 @@
                 <a:solidFill>
                   <a:srgbClr val="622B14"/>
                 </a:solidFill>
-                <a:latin typeface="Trebuchet MS"/>
+                <a:latin typeface="Segoe UI"/>
               </a:rPr>
               <a:t>Quyết định Accept, Modify, Reject</a:t>
             </a:r>
@@ -15483,7 +15483,7 @@
                 <a:solidFill>
                   <a:srgbClr val="622B14"/>
                 </a:solidFill>
-                <a:latin typeface="Trebuchet MS"/>
+                <a:latin typeface="Segoe UI"/>
               </a:rPr>
               <a:t>App Style Guide</a:t>
             </a:r>
@@ -16992,7 +16992,7 @@
                 <a:solidFill>
                   <a:srgbClr val="622B14"/>
                 </a:solidFill>
-                <a:latin typeface="Trebuchet MS"/>
+                <a:latin typeface="Segoe UI"/>
               </a:rPr>
               <a:t>Display 24 sp · Bold</a:t>
             </a:r>
@@ -17008,7 +17008,7 @@
                 <a:solidFill>
                   <a:srgbClr val="622B14"/>
                 </a:solidFill>
-                <a:latin typeface="Trebuchet MS"/>
+                <a:latin typeface="Segoe UI"/>
               </a:rPr>
               <a:t>Headline 20 sp · Bold</a:t>
             </a:r>
@@ -17367,7 +17367,7 @@
                 <a:solidFill>
                   <a:srgbClr val="622B14"/>
                 </a:solidFill>
-                <a:latin typeface="Trebuchet MS"/>
+                <a:latin typeface="Segoe UI"/>
               </a:rPr>
               <a:t>Phản biện giao diện và bản v2</a:t>
             </a:r>
@@ -18463,7 +18463,7 @@
                 <a:solidFill>
                   <a:srgbClr val="622B14"/>
                 </a:solidFill>
-                <a:latin typeface="Trebuchet MS"/>
+                <a:latin typeface="Segoe UI"/>
               </a:rPr>
               <a:t>Quy trình thiết kế P0 → P5</a:t>
             </a:r>
@@ -18757,7 +18757,7 @@
                 <a:solidFill>
                   <a:srgbClr val="622B14"/>
                 </a:solidFill>
-                <a:latin typeface="Trebuchet MS"/>
+                <a:latin typeface="Segoe UI"/>
               </a:rPr>
               <a:t>P0</a:t>
             </a:r>
@@ -18796,7 +18796,7 @@
                 <a:solidFill>
                   <a:srgbClr val="622B14"/>
                 </a:solidFill>
-                <a:latin typeface="Trebuchet MS"/>
+                <a:latin typeface="Segoe UI"/>
               </a:rPr>
               <a:t>Ideas</a:t>
             </a:r>
@@ -19053,7 +19053,7 @@
                 <a:solidFill>
                   <a:srgbClr val="622B14"/>
                 </a:solidFill>
-                <a:latin typeface="Trebuchet MS"/>
+                <a:latin typeface="Segoe UI"/>
               </a:rPr>
               <a:t>P1</a:t>
             </a:r>
@@ -19092,7 +19092,7 @@
                 <a:solidFill>
                   <a:srgbClr val="622B14"/>
                 </a:solidFill>
-                <a:latin typeface="Trebuchet MS"/>
+                <a:latin typeface="Segoe UI"/>
               </a:rPr>
               <a:t>Research</a:t>
             </a:r>
@@ -19349,7 +19349,7 @@
                 <a:solidFill>
                   <a:srgbClr val="622B14"/>
                 </a:solidFill>
-                <a:latin typeface="Trebuchet MS"/>
+                <a:latin typeface="Segoe UI"/>
               </a:rPr>
               <a:t>P2</a:t>
             </a:r>
@@ -19388,7 +19388,7 @@
                 <a:solidFill>
                   <a:srgbClr val="622B14"/>
                 </a:solidFill>
-                <a:latin typeface="Trebuchet MS"/>
+                <a:latin typeface="Segoe UI"/>
               </a:rPr>
               <a:t>UX Design</a:t>
             </a:r>
@@ -19645,7 +19645,7 @@
                 <a:solidFill>
                   <a:srgbClr val="622B14"/>
                 </a:solidFill>
-                <a:latin typeface="Trebuchet MS"/>
+                <a:latin typeface="Segoe UI"/>
               </a:rPr>
               <a:t>P3</a:t>
             </a:r>
@@ -19684,7 +19684,7 @@
                 <a:solidFill>
                   <a:srgbClr val="622B14"/>
                 </a:solidFill>
-                <a:latin typeface="Trebuchet MS"/>
+                <a:latin typeface="Segoe UI"/>
               </a:rPr>
               <a:t>UI Concept</a:t>
             </a:r>
@@ -19941,7 +19941,7 @@
                 <a:solidFill>
                   <a:srgbClr val="622B14"/>
                 </a:solidFill>
-                <a:latin typeface="Trebuchet MS"/>
+                <a:latin typeface="Segoe UI"/>
               </a:rPr>
               <a:t>P4</a:t>
             </a:r>
@@ -19980,7 +19980,7 @@
                 <a:solidFill>
                   <a:srgbClr val="622B14"/>
                 </a:solidFill>
-                <a:latin typeface="Trebuchet MS"/>
+                <a:latin typeface="Segoe UI"/>
               </a:rPr>
               <a:t>UI Design</a:t>
             </a:r>
@@ -20237,7 +20237,7 @@
                 <a:solidFill>
                   <a:srgbClr val="622B14"/>
                 </a:solidFill>
-                <a:latin typeface="Trebuchet MS"/>
+                <a:latin typeface="Segoe UI"/>
               </a:rPr>
               <a:t>P5</a:t>
             </a:r>
@@ -20276,7 +20276,7 @@
                 <a:solidFill>
                   <a:srgbClr val="622B14"/>
                 </a:solidFill>
-                <a:latin typeface="Trebuchet MS"/>
+                <a:latin typeface="Segoe UI"/>
               </a:rPr>
               <a:t>Validation</a:t>
             </a:r>
@@ -20697,7 +20697,7 @@
                 <a:solidFill>
                   <a:srgbClr val="622B14"/>
                 </a:solidFill>
-                <a:latin typeface="Trebuchet MS"/>
+                <a:latin typeface="Segoe UI"/>
               </a:rPr>
               <a:t>Final UI: luồng đặt món</a:t>
             </a:r>
@@ -22025,7 +22025,7 @@
                 <a:solidFill>
                   <a:srgbClr val="622B14"/>
                 </a:solidFill>
-                <a:latin typeface="Trebuchet MS"/>
+                <a:latin typeface="Segoe UI"/>
               </a:rPr>
               <a:t>Trạng thái hệ thống</a:t>
             </a:r>
@@ -22362,7 +22362,7 @@
                 <a:solidFill>
                   <a:srgbClr val="B45309"/>
                 </a:solidFill>
-                <a:latin typeface="Trebuchet MS"/>
+                <a:latin typeface="Segoe UI"/>
               </a:rPr>
               <a:t>EMPTY</a:t>
             </a:r>
@@ -22560,7 +22560,7 @@
                 <a:solidFill>
                   <a:srgbClr val="622B14"/>
                 </a:solidFill>
-                <a:latin typeface="Trebuchet MS"/>
+                <a:latin typeface="Segoe UI"/>
               </a:rPr>
               <a:t>LOADING</a:t>
             </a:r>
@@ -22758,7 +22758,7 @@
                 <a:solidFill>
                   <a:srgbClr val="B91C1C"/>
                 </a:solidFill>
-                <a:latin typeface="Trebuchet MS"/>
+                <a:latin typeface="Segoe UI"/>
               </a:rPr>
               <a:t>ERROR</a:t>
             </a:r>
@@ -22956,7 +22956,7 @@
                 <a:solidFill>
                   <a:srgbClr val="15803D"/>
                 </a:solidFill>
-                <a:latin typeface="Trebuchet MS"/>
+                <a:latin typeface="Segoe UI"/>
               </a:rPr>
               <a:t>SUCCESS</a:t>
             </a:r>
@@ -23156,7 +23156,7 @@
                 <a:solidFill>
                   <a:srgbClr val="622B14"/>
                 </a:solidFill>
-                <a:latin typeface="Trebuchet MS"/>
+                <a:latin typeface="Segoe UI"/>
               </a:rPr>
               <a:t>Final UI: vòng đời đơn và tài khoản</a:t>
             </a:r>
@@ -23781,7 +23781,7 @@
                 <a:solidFill>
                   <a:srgbClr val="622B14"/>
                 </a:solidFill>
-                <a:latin typeface="Trebuchet MS"/>
+                <a:latin typeface="Segoe UI"/>
               </a:rPr>
               <a:t>App người bán: BreakBite Kiosk</a:t>
             </a:r>
@@ -24412,7 +24412,7 @@
                 <a:solidFill>
                   <a:srgbClr val="622B14"/>
                 </a:solidFill>
-                <a:latin typeface="Trebuchet MS"/>
+                <a:latin typeface="Segoe UI"/>
               </a:rPr>
               <a:t>Ánh xạ pain point → màn hình (1/2)</a:t>
             </a:r>
@@ -27094,7 +27094,7 @@
                 <a:solidFill>
                   <a:srgbClr val="622B14"/>
                 </a:solidFill>
-                <a:latin typeface="Trebuchet MS"/>
+                <a:latin typeface="Segoe UI"/>
               </a:rPr>
               <a:t>Ánh xạ pain point → màn hình (2/2)</a:t>
             </a:r>
@@ -29861,7 +29861,7 @@
                 <a:solidFill>
                   <a:srgbClr val="622B14"/>
                 </a:solidFill>
-                <a:latin typeface="Trebuchet MS"/>
+                <a:latin typeface="Segoe UI"/>
               </a:rPr>
               <a:t>Bản vẽ trong Figma</a:t>
             </a:r>
@@ -30962,7 +30962,7 @@
                 <a:solidFill>
                   <a:srgbClr val="622B14"/>
                 </a:solidFill>
-                <a:latin typeface="Trebuchet MS"/>
+                <a:latin typeface="Segoe UI"/>
               </a:rPr>
               <a:t>Component và responsive</a:t>
             </a:r>
@@ -31898,7 +31898,7 @@
                 <a:solidFill>
                   <a:srgbClr val="622B14"/>
                 </a:solidFill>
-                <a:latin typeface="Trebuchet MS"/>
+                <a:latin typeface="Segoe UI"/>
               </a:rPr>
               <a:t>Prototype Figma</a:t>
             </a:r>
@@ -32725,7 +32725,7 @@
                 <a:solidFill>
                   <a:srgbClr val="622B14"/>
                 </a:solidFill>
-                <a:latin typeface="Trebuchet MS"/>
+                <a:latin typeface="Segoe UI"/>
               </a:rPr>
               <a:t>Accessibility</a:t>
             </a:r>
@@ -33060,7 +33060,7 @@
                 <a:solidFill>
                   <a:srgbClr val="B45309"/>
                 </a:solidFill>
-                <a:latin typeface="Trebuchet MS"/>
+                <a:latin typeface="Segoe UI"/>
               </a:rPr>
               <a:t>5,23:1</a:t>
             </a:r>
@@ -33200,7 +33200,7 @@
                 <a:solidFill>
                   <a:srgbClr val="B45309"/>
                 </a:solidFill>
-                <a:latin typeface="Trebuchet MS"/>
+                <a:latin typeface="Segoe UI"/>
               </a:rPr>
               <a:t>48 dp</a:t>
             </a:r>
@@ -33340,7 +33340,7 @@
                 <a:solidFill>
                   <a:srgbClr val="B45309"/>
                 </a:solidFill>
-                <a:latin typeface="Trebuchet MS"/>
+                <a:latin typeface="Segoe UI"/>
               </a:rPr>
               <a:t>14 sp</a:t>
             </a:r>
@@ -33480,7 +33480,7 @@
                 <a:solidFill>
                   <a:srgbClr val="B45309"/>
                 </a:solidFill>
-                <a:latin typeface="Trebuchet MS"/>
+                <a:latin typeface="Segoe UI"/>
               </a:rPr>
               <a:t>0</a:t>
             </a:r>
@@ -33876,7 +33876,7 @@
                 <a:solidFill>
                   <a:srgbClr val="622B14"/>
                 </a:solidFill>
-                <a:latin typeface="Trebuchet MS"/>
+                <a:latin typeface="Segoe UI"/>
               </a:rPr>
               <a:t>Vấn đề cần giải quyết</a:t>
             </a:r>
@@ -35076,7 +35076,7 @@
                 <a:solidFill>
                   <a:srgbClr val="622B14"/>
                 </a:solidFill>
-                <a:latin typeface="Trebuchet MS"/>
+                <a:latin typeface="Segoe UI"/>
               </a:rPr>
               <a:t>Kiểm thử</a:t>
             </a:r>
@@ -35903,7 +35903,7 @@
                 <a:solidFill>
                   <a:srgbClr val="622B14"/>
                 </a:solidFill>
-                <a:latin typeface="Trebuchet MS"/>
+                <a:latin typeface="Segoe UI"/>
               </a:rPr>
               <a:t>Bàn giao cho Flutter</a:t>
             </a:r>
@@ -36897,7 +36897,7 @@
                 <a:solidFill>
                   <a:srgbClr val="622B14"/>
                 </a:solidFill>
-                <a:latin typeface="Trebuchet MS"/>
+                <a:latin typeface="Segoe UI"/>
               </a:rPr>
               <a:t>Tự chấm theo Quality Gates</a:t>
             </a:r>
@@ -37234,7 +37234,7 @@
                 <a:solidFill>
                   <a:srgbClr val="622B14"/>
                 </a:solidFill>
-                <a:latin typeface="Trebuchet MS"/>
+                <a:latin typeface="Segoe UI"/>
               </a:rPr>
               <a:t>G0</a:t>
             </a:r>
@@ -37438,7 +37438,7 @@
                 <a:solidFill>
                   <a:srgbClr val="622B14"/>
                 </a:solidFill>
-                <a:latin typeface="Trebuchet MS"/>
+                <a:latin typeface="Segoe UI"/>
               </a:rPr>
               <a:t>G1</a:t>
             </a:r>
@@ -37642,7 +37642,7 @@
                 <a:solidFill>
                   <a:srgbClr val="622B14"/>
                 </a:solidFill>
-                <a:latin typeface="Trebuchet MS"/>
+                <a:latin typeface="Segoe UI"/>
               </a:rPr>
               <a:t>G2</a:t>
             </a:r>
@@ -37846,7 +37846,7 @@
                 <a:solidFill>
                   <a:srgbClr val="622B14"/>
                 </a:solidFill>
-                <a:latin typeface="Trebuchet MS"/>
+                <a:latin typeface="Segoe UI"/>
               </a:rPr>
               <a:t>G3</a:t>
             </a:r>
@@ -38050,7 +38050,7 @@
                 <a:solidFill>
                   <a:srgbClr val="622B14"/>
                 </a:solidFill>
-                <a:latin typeface="Trebuchet MS"/>
+                <a:latin typeface="Segoe UI"/>
               </a:rPr>
               <a:t>G4</a:t>
             </a:r>
@@ -38254,7 +38254,7 @@
                 <a:solidFill>
                   <a:srgbClr val="622B14"/>
                 </a:solidFill>
-                <a:latin typeface="Trebuchet MS"/>
+                <a:latin typeface="Segoe UI"/>
               </a:rPr>
               <a:t>G5</a:t>
             </a:r>
@@ -38760,7 +38760,7 @@
                 <a:solidFill>
                   <a:srgbClr val="622B14"/>
                 </a:solidFill>
-                <a:latin typeface="Trebuchet MS"/>
+                <a:latin typeface="Segoe UI"/>
               </a:rPr>
               <a:t>Tổng kết</a:t>
             </a:r>
@@ -39010,7 +39010,7 @@
                 <a:solidFill>
                   <a:srgbClr val="622B14"/>
                 </a:solidFill>
-                <a:latin typeface="Trebuchet MS"/>
+                <a:latin typeface="Segoe UI"/>
               </a:rPr>
               <a:t>AI giúp</a:t>
             </a:r>
@@ -39184,7 +39184,7 @@
                 <a:solidFill>
                   <a:srgbClr val="622B14"/>
                 </a:solidFill>
-                <a:latin typeface="Trebuchet MS"/>
+                <a:latin typeface="Segoe UI"/>
               </a:rPr>
               <a:t>Nhóm vẫn phải</a:t>
             </a:r>
@@ -39358,7 +39358,7 @@
                 <a:solidFill>
                   <a:srgbClr val="B45309"/>
                 </a:solidFill>
-                <a:latin typeface="Trebuchet MS"/>
+                <a:latin typeface="Segoe UI"/>
               </a:rPr>
               <a:t>Còn lại</a:t>
             </a:r>
@@ -39530,7 +39530,7 @@
                 <a:solidFill>
                   <a:srgbClr val="622B14"/>
                 </a:solidFill>
-                <a:latin typeface="Trebuchet MS"/>
+                <a:latin typeface="Segoe UI"/>
               </a:rPr>
               <a:t>Cảm ơn thầy và các bạn</a:t>
             </a:r>
@@ -39635,7 +39635,7 @@
                 <a:solidFill>
                   <a:srgbClr val="622B14"/>
                 </a:solidFill>
-                <a:latin typeface="Trebuchet MS"/>
+                <a:latin typeface="Segoe UI"/>
               </a:rPr>
               <a:t>Các hướng đã cân nhắc</a:t>
             </a:r>
@@ -40817,7 +40817,7 @@
                 <a:solidFill>
                   <a:srgbClr val="622B14"/>
                 </a:solidFill>
-                <a:latin typeface="Trebuchet MS"/>
+                <a:latin typeface="Segoe UI"/>
               </a:rPr>
               <a:t>Giả định, rủi ro và phạm vi MVP</a:t>
             </a:r>
@@ -42084,7 +42084,7 @@
                 <a:solidFill>
                   <a:srgbClr val="622B14"/>
                 </a:solidFill>
-                <a:latin typeface="Trebuchet MS"/>
+                <a:latin typeface="Segoe UI"/>
               </a:rPr>
               <a:t>Kế hoạch nghiên cứu</a:t>
             </a:r>
@@ -43590,7 +43590,7 @@
                 <a:solidFill>
                   <a:srgbClr val="622B14"/>
                 </a:solidFill>
-                <a:latin typeface="Trebuchet MS"/>
+                <a:latin typeface="Segoe UI"/>
               </a:rPr>
               <a:t>Kết quả nghiên cứu hiện có</a:t>
             </a:r>
@@ -43964,7 +43964,7 @@
                 <a:solidFill>
                   <a:srgbClr val="B45309"/>
                 </a:solidFill>
-                <a:latin typeface="Trebuchet MS"/>
+                <a:latin typeface="Segoe UI"/>
               </a:rPr>
               <a:t>4 / 5</a:t>
             </a:r>
@@ -44088,7 +44088,7 @@
                 <a:solidFill>
                   <a:srgbClr val="B45309"/>
                 </a:solidFill>
-                <a:latin typeface="Trebuchet MS"/>
+                <a:latin typeface="Segoe UI"/>
               </a:rPr>
               <a:t>3 / 5</a:t>
             </a:r>
@@ -44212,7 +44212,7 @@
                 <a:solidFill>
                   <a:srgbClr val="B45309"/>
                 </a:solidFill>
-                <a:latin typeface="Trebuchet MS"/>
+                <a:latin typeface="Segoe UI"/>
               </a:rPr>
               <a:t>1 / 5</a:t>
             </a:r>
@@ -44375,7 +44375,7 @@
                 <a:solidFill>
                   <a:srgbClr val="B45309"/>
                 </a:solidFill>
-                <a:latin typeface="Trebuchet MS"/>
+                <a:latin typeface="Segoe UI"/>
               </a:rPr>
               <a:t>4,5 / 5</a:t>
             </a:r>
@@ -44499,7 +44499,7 @@
                 <a:solidFill>
                   <a:srgbClr val="B45309"/>
                 </a:solidFill>
-                <a:latin typeface="Trebuchet MS"/>
+                <a:latin typeface="Segoe UI"/>
               </a:rPr>
               <a:t>0 / 20</a:t>
             </a:r>
@@ -44623,7 +44623,7 @@
                 <a:solidFill>
                   <a:srgbClr val="B45309"/>
                 </a:solidFill>
-                <a:latin typeface="Trebuchet MS"/>
+                <a:latin typeface="Segoe UI"/>
               </a:rPr>
               <a:t>9 / 20</a:t>
             </a:r>
@@ -44836,7 +44836,7 @@
                 <a:solidFill>
                   <a:srgbClr val="622B14"/>
                 </a:solidFill>
-                <a:latin typeface="Trebuchet MS"/>
+                <a:latin typeface="Segoe UI"/>
               </a:rPr>
               <a:t>Insight → quyết định thiết kế</a:t>
             </a:r>
@@ -46637,7 +46637,7 @@
                 <a:solidFill>
                   <a:srgbClr val="622B14"/>
                 </a:solidFill>
-                <a:latin typeface="Trebuchet MS"/>
+                <a:latin typeface="Segoe UI"/>
               </a:rPr>
               <a:t>Persona</a:t>
             </a:r>
@@ -47018,7 +47018,7 @@
                 <a:solidFill>
                   <a:srgbClr val="622B14"/>
                 </a:solidFill>
-                <a:latin typeface="Trebuchet MS"/>
+                <a:latin typeface="Segoe UI"/>
               </a:rPr>
               <a:t>Q</a:t>
             </a:r>
@@ -47339,7 +47339,7 @@
                 <a:solidFill>
                   <a:srgbClr val="622B14"/>
                 </a:solidFill>
-                <a:latin typeface="Trebuchet MS"/>
+                <a:latin typeface="Segoe UI"/>
               </a:rPr>
               <a:t>L</a:t>
             </a:r>
@@ -47660,7 +47660,7 @@
                 <a:solidFill>
                   <a:srgbClr val="622B14"/>
                 </a:solidFill>
-                <a:latin typeface="Trebuchet MS"/>
+                <a:latin typeface="Segoe UI"/>
               </a:rPr>
               <a:t>H</a:t>
             </a:r>
@@ -47981,7 +47981,7 @@
                 <a:solidFill>
                   <a:srgbClr val="622B14"/>
                 </a:solidFill>
-                <a:latin typeface="Trebuchet MS"/>
+                <a:latin typeface="Segoe UI"/>
               </a:rPr>
               <a:t>T</a:t>
             </a:r>

</xml_diff>